<commit_message>
Replace Figure 10 with the 6 h North Atlantic four-panel capture
The old Figure 10 was the 20 Sep 06Z 48 h four-panel taken with the
workstation colormap ranges before CPS_CoreDiverging and CPS_Asymmetry
were installed. It now shows the 6 h frame of the 24 Sep 06Z GFS run on
the North Atlantic with the installed colormaps, centered on the 959 hPa
warm seclusion south of Greenland. The caption, the Atlantic results
paragraph, the talk deck slide 8 and its notes follow the new figure.

Co-Authored-By: Claude Fable 5.1 <noreply@anthropic.com>
Claude-Session: https://claude.ai/code/session_019q8NWWmgCfoxLvyzmCH4VN
</commit_message>
<xml_diff>
--- a/cyclone_phase_space/docs/TALK.pptx
+++ b/cyclone_phase_space/docs/TALK.pptx
@@ -1219,7 +1219,7 @@
           <a:p>
             <a:r>
               <a:rPr lang="en-US" dirty="0"/>
-              <a:t>This is the operational display: four fields, HVTL, HVTU, the joint class, and the index. The capture is the 48 hour frame of the 20 September run, the storm east of Japan at 976 millibars, class 3, with B at 36, the lower term at 114 and the upper at minus 102. The class reads at the storm's center, one number for one of seven classes built from Hart's two diagrams: symmetric or asymmetric, deep or shallow warm core, cold core, or shallow cold core, lower cold and upper warm, a rare state. Step through the frames on a transitioning storm and the class climbs 0, then 2, then 3, then 4; a warm seclusion runs it from 4 to 3, or to 1 if B falls too. Load a second model beside it and compare the hour each HB crosses 10 meters and each HVTL crosses zero; where they disagree is your transition uncertainty. That's not something we've had inside our own workstation before, because it needed a tracker for every model.</a:t>
+              <a:t>This is the operational display: four fields, HVTL, HVTU, the joint class, and the index. The capture is the North Atlantic at 6 hours of the 24 September run: HB paints the polar front magenta, HVTU is blue under the jet, and the 959 millibar low south of Greenland reads as a warm seclusion, red lower core, blue upper, B near zero at the center with the magenta band wrapped around it. The class reads at the storm's center, one number for one of seven classes built from Hart's two diagrams: symmetric or asymmetric, deep or shallow warm core, cold core, or shallow cold core, lower cold and upper warm, a rare state. Step through the frames on a transitioning storm and the class climbs 0, then 2, then 3, then 4; a warm seclusion runs it from 4 to 3, or to 1 if B falls too. Load a second model beside it and compare the hour each HB crosses 10 meters and each HVTL crosses zero; where they disagree is your transition uncertainty. That's not something we've had inside our own workstation before, because it needed a tracker for every model.</a:t>
             </a:r>
             <a:endParaRPr lang="en-US" dirty="0"/>
           </a:p>
@@ -1833,8 +1833,8 @@
         </p:blipFill>
         <p:spPr>
           <a:xfrm>
-            <a:off x="4663440" y="1550568"/>
-            <a:ext cx="4206240" cy="2042363"/>
+            <a:off x="4663440" y="1499159"/>
+            <a:ext cx="4206240" cy="2145182"/>
           </a:xfrm>
           <a:prstGeom prst="rect">
             <a:avLst/>
@@ -4116,7 +4116,7 @@
         <p:spPr>
           <a:xfrm>
             <a:off x="457200" y="914400"/>
-            <a:ext cx="5394960" cy="2619553"/>
+            <a:ext cx="5394960" cy="2751430"/>
           </a:xfrm>
           <a:prstGeom prst="rect">
             <a:avLst/>
@@ -4131,7 +4131,7 @@
         </p:nvSpPr>
         <p:spPr>
           <a:xfrm>
-            <a:off x="457200" y="3607105"/>
+            <a:off x="457200" y="3738982"/>
             <a:ext cx="5394960" cy="548640"/>
           </a:xfrm>
           <a:prstGeom prst="rect">
@@ -4156,7 +4156,7 @@
                 <a:ea typeface="Calibri" pitchFamily="34" charset="-122"/>
                 <a:cs typeface="Calibri" pitchFamily="34" charset="-120"/>
               </a:rPr>
-              <a:t>CAVE four-panel procedure, 48 h of the 20 Sep 06Z GFS: class (top left), B (top right), HVTL and HVTU (bottom left), index (bottom right). Storm at 976 mb: class 3, B 36 m, HVTL +114 m, HVTU -102 m.</a:t>
+              <a:t>CAVE four-panel on the North Atlantic, 6 h of the 24 Sep 06Z GFS: class (top left), HB (top right), HVTL with 850 hPa wind (bottom left), HVTU with 300 hPa wind (bottom right). The 959 mb low south of Greenland reads as a warm seclusion: red HVTL, blue HVTU, HB near zero at the center, class 3 with 1 on the flanks.</a:t>
             </a:r>
             <a:endParaRPr lang="en-US" sz="1000" dirty="0"/>
           </a:p>

</xml_diff>

<commit_message>
Update the talk deck for semicircle B, the MSLP detector and new timing
Speaker notes name sea level pressure as the detector input, the
validation notes flag the logged B values as sampled with the former
form, the limits slide states the standard-level band bias and the
synthetic agreement of the semicircle B with Hart, and the cost reads
2.7 s per frame.

Co-Authored-By: Claude Fable 5.1 <noreply@anthropic.com>
Claude-Session: https://claude.ai/code/session_019q8NWWmgCfoxLvyzmCH4VN
</commit_message>
<xml_diff>
--- a/cyclone_phase_space/docs/TALK.pptx
+++ b/cyclone_phase_space/docs/TALK.pptx
@@ -599,7 +599,7 @@
           <a:p>
             <a:r>
               <a:rPr lang="en-US" dirty="0"/>
-              <a:t>Honest limits: we use standard levels, not Hart's 50 hectopascal spacing, so magnitudes are near his but not identical. The window is a square, which carries a small cold bias on a strong gradient. B and the transition-onset field are implemented but not yet validated. And it's three cases, not a season.
+              <a:t>Honest limits: we use standard levels, not Hart's 50 hectopascal spacing, so magnitudes are near his but not identical. The standard-level band reads a deep warm core about 12 percent high and a warm seclusion two to three times Hart's value; the square window adds almost nothing for compact storms. B is now computed from true semicircle means and matches Hart's within one percent on a synthetic life cycle, with onset at the same hour, but it has not yet been validated on a real storm. And it's a handful of cases, not a season.
 Next is a season of use, a model-comparison product for transition timing, and a storm-centered diagram inside GFE. The package, guides, and tests are in the repository. Questions.</a:t>
             </a:r>
             <a:endParaRPr lang="en-US" dirty="0"/>
@@ -1043,7 +1043,7 @@
             <a:r>
               <a:rPr lang="en-US" dirty="0"/>
               <a:t>Until now, operational access was the FSU cyclone phase page: storm-centered diagrams for tracker-identified cyclones, in a fixed set of models, outside the workstation. What OPC needs is the same diagnostic inside D2D, on every model we run, for any low we point at.
-We reformulated the parameters as gridded fields and implemented them as AWIPS derived parameters. At every grid point the code evaluates the height range inside a 500 kilometer window at each level and regresses it against log pressure: Hart's own definition, evaluated everywhere instead of at one tracked center. The square window and standard levels keep the magnitudes close to his, not identical. It needs geopotential height on standard levels and surface pressure; the asymmetric term also needs winds at four levels. That runs on any model in D2D carrying those fields, with no tracker and no advisory. A closed-low detector on the 1000 hPa height keeps the class off open ocean and open troughs in the cases we've tested, and terrain is masked below ground.</a:t>
+We reformulated the parameters as gridded fields and implemented them as AWIPS derived parameters. At every grid point the code evaluates the height range inside a 500 kilometer window at each level and regresses it against log pressure: Hart's own definition, evaluated everywhere instead of at one tracked center. The square window and standard levels keep the magnitudes close to his, not identical. It needs geopotential height on standard levels, surface pressure and sea level pressure; the asymmetric term also needs winds at four levels. That runs on any model in D2D carrying those fields, with no tracker and no advisory. A closed-low detector on sea level pressure keeps the class off open ocean and open troughs in the cases we've tested, and terrain is masked below ground.</a:t>
             </a:r>
             <a:endParaRPr lang="en-US" dirty="0"/>
           </a:p>
@@ -1307,7 +1307,7 @@
           <a:p>
             <a:r>
               <a:rPr lang="en-US" dirty="0"/>
-              <a:t>Three checks so far, all GFS cases from one model cycle: a smoke test, not a calibration. A typhoon at 984 millibars read 120 and 180 meters, a deep warm core; our bands differ from Hart's, so we don't compare that magnitude to his published values. For Typhoon Dujuan, the 2026 September 17, 1200 UTC GFS run valid 21 September 1800 UTC: the hour the class left its deep warm core state matched the hour FSU's page showed deep to shallow warm core, within one 6 hour frame. A deep North Atlantic low in the same cycle classified cold core; its values weren't recorded, so that case needs re-sampling. Greenland and the Rockies come out blank rather than contaminated. Compute cost is about 2.6 seconds per forecast hour on the full global grid, the median of four runs, ranging 2.4 to 3.0 seconds.</a:t>
+              <a:t>Checks so far are GFS cases from five cycles, sampled by hand: a smoke test, not a calibration. A typhoon at 984 millibars read 120 and 180 meters, a deep warm core; our bands differ from Hart's, so we don't compare that magnitude to his published values. For Typhoon Dujuan, the 2026 September 17, 1200 UTC GFS run valid 21 September 1800 UTC: the hour the class left its deep warm core state matched the hour FSU's page showed deep to shallow warm core, within one 6 hour frame. A deep North Atlantic low in the same cycle classified cold core; its values weren't recorded, so that case needs re-sampling. Greenland and the Rockies come out blank rather than contaminated. Compute cost is about 2.7 seconds per forecast hour on the full global grid, the median of four runs, ranging 2.5 to 2.9 seconds.</a:t>
             </a:r>
             <a:endParaRPr lang="en-US" dirty="0"/>
           </a:p>
@@ -1974,7 +1974,7 @@
           <a:p>
             <a:pPr algn="l" marL="342900" indent="-342900">
               <a:spcAft>
-                <a:spcPts val="1000"/>
+                <a:spcPts val="800"/>
               </a:spcAft>
               <a:buSzPct val="100000"/>
               <a:buChar char="•"/>
@@ -1988,14 +1988,14 @@
                 <a:ea typeface="Calibri" pitchFamily="34" charset="-122"/>
                 <a:cs typeface="Calibri" pitchFamily="34" charset="-120"/>
               </a:rPr>
-              <a:t>Standard levels, not Hart's 50 hPa spacing</a:t>
+              <a:t>Standard levels, not Hart's 50 hPa: deep warm core reads 12% high, seclusion 2 to 3 times his</a:t>
             </a:r>
             <a:endParaRPr lang="en-US" sz="1600" dirty="0"/>
           </a:p>
           <a:p>
             <a:pPr algn="l" marL="342900" indent="-342900">
               <a:spcAft>
-                <a:spcPts val="1000"/>
+                <a:spcPts val="800"/>
               </a:spcAft>
               <a:buSzPct val="100000"/>
               <a:buChar char="•"/>
@@ -2009,28 +2009,7 @@
                 <a:ea typeface="Calibri" pitchFamily="34" charset="-122"/>
                 <a:cs typeface="Calibri" pitchFamily="34" charset="-120"/>
               </a:rPr>
-              <a:t>Square window: small cold bias on strong gradients</a:t>
-            </a:r>
-            <a:endParaRPr lang="en-US" sz="1600" dirty="0"/>
-          </a:p>
-          <a:p>
-            <a:pPr algn="l" marL="342900" indent="-342900">
-              <a:spcAft>
-                <a:spcPts val="1000"/>
-              </a:spcAft>
-              <a:buSzPct val="100000"/>
-              <a:buChar char="•"/>
-            </a:pPr>
-            <a:r>
-              <a:rPr lang="en-US" sz="1600" dirty="0">
-                <a:solidFill>
-                  <a:srgbClr val="FFFFFF"/>
-                </a:solidFill>
-                <a:latin typeface="Calibri" pitchFamily="34" charset="0"/>
-                <a:ea typeface="Calibri" pitchFamily="34" charset="-122"/>
-                <a:cs typeface="Calibri" pitchFamily="34" charset="-120"/>
-              </a:rPr>
-              <a:t>B and transition onset implemented, not yet validated</a:t>
+              <a:t>B from semicircle means matches Hart on a synthetic life cycle; no real-storm check yet</a:t>
             </a:r>
             <a:endParaRPr lang="en-US" sz="1600" dirty="0"/>
           </a:p>
@@ -2048,7 +2027,7 @@
                 <a:ea typeface="Calibri" pitchFamily="34" charset="-122"/>
                 <a:cs typeface="Calibri" pitchFamily="34" charset="-120"/>
               </a:rPr>
-              <a:t>Three cases, not a season</a:t>
+              <a:t>A handful of cases, not a season</a:t>
             </a:r>
             <a:endParaRPr lang="en-US" sz="1600" dirty="0"/>
           </a:p>
@@ -4728,7 +4707,7 @@
                 <a:ea typeface="Cambria" pitchFamily="34" charset="-122"/>
                 <a:cs typeface="Cambria" pitchFamily="34" charset="-120"/>
               </a:rPr>
-              <a:t>about 2.6 s</a:t>
+              <a:t>about 2.7 s</a:t>
             </a:r>
             <a:endParaRPr lang="en-US" sz="3000" dirty="0"/>
           </a:p>
@@ -4767,7 +4746,7 @@
                 <a:ea typeface="Calibri" pitchFamily="34" charset="-122"/>
                 <a:cs typeface="Calibri" pitchFamily="34" charset="-120"/>
               </a:rPr>
-              <a:t>per forecast hour, 0.25° global grid (median of 4 runs, 2.4–3.0 s)</a:t>
+              <a:t>per forecast hour, 0.25° global grid (median of 4 runs, 2.5–2.9 s)</a:t>
             </a:r>
             <a:endParaRPr lang="en-US" sz="1300" dirty="0"/>
           </a:p>

</xml_diff>

<commit_message>
Add the three-dimensional phase space figure and an interactive version
HCPSclass is a partition of Hart's (B, -VTL, -VTU) space into seven
cells, so the article now shows that space directly: new Figure 7
draws the cells as translucent boxes in the class colors, cut by the
planes B = 10 m, -VTL = 0 and -VTU = 0, with the synthetic life cycle
of Hart's method and the gridded method threading through them from
two viewing angles, and a self-contained Plotly page beside it that
can be rotated and read by hovering, embedded under the figure and
linked. phase_space_3d.py builds both from lifecycle_comparison.py's
functions. Figures 7 to 18 become 8 to 19 throughout the article and
its appendix. The technical and user guides carry the figure, the
deck's diagram slide shows panel (a), and the README lists the script
and the page.

Co-Authored-By: Claude Fable 5.1 <noreply@anthropic.com>
Claude-Session: https://claude.ai/code/session_019q8NWWmgCfoxLvyzmCH4VN
</commit_message>
<xml_diff>
--- a/cyclone_phase_space/docs/TALK.pptx
+++ b/cyclone_phase_space/docs/TALK.pptx
@@ -954,7 +954,7 @@
           <a:p>
             <a:r>
               <a:rPr lang="en-US" dirty="0"/>
-              <a:t>Put those together and you get Hart's two diagrams. On the left, B against the lower thermal wind: symmetric or asymmetric, warm or cold. On the right, lower against upper thermal wind: deep warm, shallow warm, or cold. A hurricane starts in the deep warm corner; during transition it crosses the B line first, loses the upper warm core, then the lower one, and ends in the cold corner. Some storms hook back toward shallow warm core: a warm seclusion re-forming a warm core at the surface, the ones that deepen unexpectedly over cold water. The product we built turns all three numbers into one, so a forecaster reads a single class instead of two diagrams. For a marine center, transition is when the wind field expands, so these crossings are the forecast question.</a:t>
+              <a:t>Put those together and you get Hart's two diagrams. On the left, B against the lower thermal wind: symmetric or asymmetric, warm or cold. On the right, lower against upper thermal wind: deep warm, shallow warm, or cold. A hurricane starts in the deep warm corner; during transition it crosses the B line first, loses the upper warm core, then the lower one, and ends in the cold corner. Some storms hook back toward shallow warm core: a warm seclusion re-forming a warm core at the surface, the ones that deepen unexpectedly over cold water. The product we built turns all three numbers into one, so a forecaster reads a single class instead of two diagrams. The class is the cell of Hart's three-dimensional space the storm falls in, and the two diagrams are that space's projections, which is the picture on the right. For a marine center, transition is when the wind field expands, so these crossings are the forecast question.</a:t>
             </a:r>
             <a:endParaRPr lang="en-US" dirty="0"/>
           </a:p>
@@ -3257,24 +3257,47 @@
         </p:blipFill>
         <p:spPr>
           <a:xfrm>
-            <a:off x="1234440" y="713232"/>
-            <a:ext cx="6675120" cy="3397718"/>
+            <a:off x="457200" y="1003526"/>
+            <a:ext cx="4572000" cy="2327204"/>
           </a:xfrm>
           <a:prstGeom prst="rect">
             <a:avLst/>
           </a:prstGeom>
         </p:spPr>
       </p:pic>
-      <p:sp>
-        <p:nvSpPr>
-          <p:cNvPr id="4" name="Text 1"/>
-          <p:cNvSpPr txBox="1"/>
-          <p:nvPr/>
-        </p:nvSpPr>
-        <p:spPr>
-          <a:xfrm>
-            <a:off x="457200" y="4165814"/>
-            <a:ext cx="8229600" cy="320040"/>
+      <p:pic>
+        <p:nvPicPr>
+          <p:cNvPr id="4" name="Image 1" descr="/home/user/awips-tools/cyclone_phase_space/article/figures/figJ_phase_space_3d.png">    </p:cNvPr>
+          <p:cNvPicPr>
+            <a:picLocks noChangeAspect="1"/>
+          </p:cNvPicPr>
+          <p:nvPr/>
+        </p:nvPicPr>
+        <p:blipFill>
+          <a:blip r:embed="rId2"/>
+          <a:srcRect l="4167" r="51667" t="7627" b="12712"/>
+          <a:stretch/>
+        </p:blipFill>
+        <p:spPr>
+          <a:xfrm>
+            <a:off x="5284065" y="658368"/>
+            <a:ext cx="3402735" cy="3017520"/>
+          </a:xfrm>
+          <a:prstGeom prst="rect">
+            <a:avLst/>
+          </a:prstGeom>
+        </p:spPr>
+      </p:pic>
+      <p:sp>
+        <p:nvSpPr>
+          <p:cNvPr id="5" name="Text 1"/>
+          <p:cNvSpPr txBox="1"/>
+          <p:nvPr/>
+        </p:nvSpPr>
+        <p:spPr>
+          <a:xfrm>
+            <a:off x="457200" y="3403882"/>
+            <a:ext cx="4572000" cy="457200"/>
           </a:xfrm>
           <a:prstGeom prst="rect">
             <a:avLst/>
@@ -3306,7 +3329,46 @@
       </p:sp>
       <p:sp>
         <p:nvSpPr>
-          <p:cNvPr id="5" name="Text 2"/>
+          <p:cNvPr id="6" name="Text 2"/>
+          <p:cNvSpPr txBox="1"/>
+          <p:nvPr/>
+        </p:nvSpPr>
+        <p:spPr>
+          <a:xfrm>
+            <a:off x="5284065" y="3730752"/>
+            <a:ext cx="3402735" cy="457200"/>
+          </a:xfrm>
+          <a:prstGeom prst="rect">
+            <a:avLst/>
+          </a:prstGeom>
+          <a:noFill/>
+          <a:ln/>
+        </p:spPr>
+        <p:txBody>
+          <a:bodyPr wrap="square" lIns="0" tIns="0" rIns="0" bIns="0" rtlCol="0" anchor="t"/>
+          <a:lstStyle/>
+          <a:p>
+            <a:pPr algn="ctr" indent="0" marL="0">
+              <a:buNone/>
+            </a:pPr>
+            <a:r>
+              <a:rPr lang="en-US" sz="1200" i="1" dirty="0">
+                <a:solidFill>
+                  <a:srgbClr val="52514E"/>
+                </a:solidFill>
+                <a:latin typeface="Calibri" pitchFamily="34" charset="0"/>
+                <a:ea typeface="Calibri" pitchFamily="34" charset="-122"/>
+                <a:cs typeface="Calibri" pitchFamily="34" charset="-120"/>
+              </a:rPr>
+              <a:t>One 3-D space, seven boxes: the class is the box the storm's point sits in.</a:t>
+            </a:r>
+            <a:endParaRPr lang="en-US" sz="1200" dirty="0"/>
+          </a:p>
+        </p:txBody>
+      </p:sp>
+      <p:sp>
+        <p:nvSpPr>
+          <p:cNvPr id="7" name="Text 3"/>
           <p:cNvSpPr txBox="1"/>
           <p:nvPr/>
         </p:nvSpPr>
@@ -3345,7 +3407,7 @@
       </p:sp>
       <p:sp>
         <p:nvSpPr>
-          <p:cNvPr id="6" name="Text 3"/>
+          <p:cNvPr id="8" name="Text 4"/>
           <p:cNvSpPr txBox="1"/>
           <p:nvPr/>
         </p:nvSpPr>
@@ -3384,7 +3446,7 @@
       </p:sp>
       <p:sp>
         <p:nvSpPr>
-          <p:cNvPr id="7" name="Text 4"/>
+          <p:cNvPr id="9" name="Text 5"/>
           <p:cNvSpPr txBox="1"/>
           <p:nvPr/>
         </p:nvSpPr>

</xml_diff>